<commit_message>
Update itdd-technical-debt to use renvation effort
</commit_message>
<xml_diff>
--- a/src/report_generator/presets/templates/itdd-technical-debt.pptx
+++ b/src/report_generator/presets/templates/itdd-technical-debt.pptx
@@ -262,7 +262,7 @@
           <a:p>
             <a:fld id="{C1255C68-584F-174D-BB81-51BF91708794}" type="datetimeFigureOut">
               <a:rPr lang="en-US" smtClean="0"/>
-              <a:t>5/28/25</a:t>
+              <a:t>1/29/26</a:t>
             </a:fld>
             <a:endParaRPr lang="en-US"/>
           </a:p>
@@ -439,7 +439,7 @@
           <a:p>
             <a:fld id="{A1EDAAC4-819D-C544-9EA1-C73624CFD70B}" type="datetimeFigureOut">
               <a:rPr lang="en-US" smtClean="0"/>
-              <a:t>5/28/25</a:t>
+              <a:t>1/29/26</a:t>
             </a:fld>
             <a:endParaRPr lang="en-US"/>
           </a:p>
@@ -24458,7 +24458,15 @@
           <a:p>
             <a:r>
               <a:rPr lang="en-US" dirty="0"/>
-              <a:t>SYSTEM_NAME technical debt is TECHNICAL_DEBT_PY person years (TECHNICAL_DEBT_PERCENTAGE% of its volume)</a:t>
+              <a:t>SYSTEM_NAME technical debt </a:t>
+            </a:r>
+            <a:r>
+              <a:rPr lang="en-US"/>
+              <a:t>is RENOVATION_EFFORT_PY person </a:t>
+            </a:r>
+            <a:r>
+              <a:rPr lang="en-US" dirty="0"/>
+              <a:t>years (RENOVATION_EFFORT_PERCENTAGE% of its volume)</a:t>
             </a:r>
           </a:p>
         </p:txBody>
@@ -24688,7 +24696,7 @@
           <a:p>
             <a:r>
               <a:rPr lang="en-US" dirty="0"/>
-              <a:t>Approximately TECHNICAL_DEBT_PY person years is required to renovate the system towards the recommended 4-star level</a:t>
+              <a:t>Approximately RENOVATION_EFFORT_PY person years is required to renovate the system towards the recommended 4-star level</a:t>
             </a:r>
           </a:p>
         </p:txBody>
@@ -24708,14 +24716,14 @@
           <p:nvPr>
             <p:extLst>
               <p:ext uri="{D42A27DB-BD31-4B8C-83A1-F6EECF244321}">
-                <p14:modId xmlns:p14="http://schemas.microsoft.com/office/powerpoint/2010/main" val="109948998"/>
+                <p14:modId xmlns:p14="http://schemas.microsoft.com/office/powerpoint/2010/main" val="2057082069"/>
               </p:ext>
             </p:extLst>
           </p:nvPr>
         </p:nvGraphicFramePr>
         <p:xfrm>
           <a:off x="514374" y="4679176"/>
-          <a:ext cx="7567186" cy="1141440"/>
+          <a:ext cx="7567186" cy="1354800"/>
         </p:xfrm>
         <a:graphic>
           <a:graphicData uri="http://schemas.openxmlformats.org/drawingml/2006/table">
@@ -25223,7 +25231,23 @@
                     <a:bodyPr/>
                     <a:lstStyle/>
                     <a:p>
-                      <a:pPr algn="ctr" fontAlgn="b"/>
+                      <a:pPr marL="0" marR="0" indent="0" algn="ctr" defTabSz="914400" rtl="0" eaLnBrk="1" fontAlgn="b" latinLnBrk="0" hangingPunct="1">
+                        <a:lnSpc>
+                          <a:spcPct val="100000"/>
+                        </a:lnSpc>
+                        <a:spcBef>
+                          <a:spcPts val="0"/>
+                        </a:spcBef>
+                        <a:spcAft>
+                          <a:spcPts val="0"/>
+                        </a:spcAft>
+                        <a:buClrTx/>
+                        <a:buSzTx/>
+                        <a:buFontTx/>
+                        <a:buNone/>
+                        <a:tabLst/>
+                        <a:defRPr/>
+                      </a:pPr>
                       <a:r>
                         <a:rPr lang="en-US" sz="1400" b="0" i="0" u="none" strike="noStrike" noProof="0" dirty="0">
                           <a:solidFill>
@@ -25232,25 +25256,8 @@
                           <a:effectLst/>
                           <a:latin typeface="Calibri Regular"/>
                         </a:rPr>
-                        <a:t>TECHNICAL_DEBT_PY </a:t>
+                        <a:t>RENOVATION_EFFORT PY</a:t>
                       </a:r>
-                      <a:r>
-                        <a:rPr lang="en-US" sz="1400" b="0" i="0" u="none" strike="noStrike" noProof="0" dirty="0" err="1">
-                          <a:solidFill>
-                            <a:srgbClr val="000000"/>
-                          </a:solidFill>
-                          <a:effectLst/>
-                          <a:latin typeface="Calibri Regular"/>
-                        </a:rPr>
-                        <a:t>PY</a:t>
-                      </a:r>
-                      <a:endParaRPr lang="en-US" sz="1400" b="0" i="0" u="none" strike="noStrike" noProof="0" dirty="0">
-                        <a:solidFill>
-                          <a:srgbClr val="000000"/>
-                        </a:solidFill>
-                        <a:effectLst/>
-                        <a:latin typeface="Calibri Regular"/>
-                      </a:endParaRPr>
                     </a:p>
                   </a:txBody>
                   <a:tcPr marL="108000" marR="108000" marT="72000" marB="72000" anchor="ctr">
@@ -26953,26 +26960,6 @@
 </file>
 
 <file path=customXml/item1.xml><?xml version="1.0" encoding="utf-8"?>
-<p:properties xmlns:p="http://schemas.microsoft.com/office/2006/metadata/properties" xmlns:xsi="http://www.w3.org/2001/XMLSchema-instance" xmlns:pc="http://schemas.microsoft.com/office/infopath/2007/PartnerControls">
-  <documentManagement>
-    <lcf76f155ced4ddcb4097134ff3c332f xmlns="fa937df2-abe2-4d38-b5f4-c228acba3827">
-      <Terms xmlns="http://schemas.microsoft.com/office/infopath/2007/PartnerControls"/>
-    </lcf76f155ced4ddcb4097134ff3c332f>
-    <TaxCatchAll xmlns="bc8ba18a-4a58-4ad2-bfc0-6516af8e7dc2" xsi:nil="true"/>
-  </documentManagement>
-</p:properties>
-</file>
-
-<file path=customXml/item2.xml><?xml version="1.0" encoding="utf-8"?>
-<?mso-contentType ?>
-<FormTemplates xmlns="http://schemas.microsoft.com/sharepoint/v3/contenttype/forms">
-  <Display>DocumentLibraryForm</Display>
-  <Edit>DocumentLibraryForm</Edit>
-  <New>DocumentLibraryForm</New>
-</FormTemplates>
-</file>
-
-<file path=customXml/item3.xml><?xml version="1.0" encoding="utf-8"?>
 <ct:contentTypeSchema xmlns:ct="http://schemas.microsoft.com/office/2006/metadata/contentType" xmlns:ma="http://schemas.microsoft.com/office/2006/metadata/properties/metaAttributes" ct:_="" ma:_="" ma:contentTypeName="Document" ma:contentTypeID="0x010100398B4EB28540854BB4092730D7F67224" ma:contentTypeVersion="13" ma:contentTypeDescription="Create a new document." ma:contentTypeScope="" ma:versionID="07d6997c7358ecc3b6f0d78039f1ac55">
   <xsd:schema xmlns:xsd="http://www.w3.org/2001/XMLSchema" xmlns:xs="http://www.w3.org/2001/XMLSchema" xmlns:p="http://schemas.microsoft.com/office/2006/metadata/properties" xmlns:ns2="fa937df2-abe2-4d38-b5f4-c228acba3827" xmlns:ns3="bc8ba18a-4a58-4ad2-bfc0-6516af8e7dc2" targetNamespace="http://schemas.microsoft.com/office/2006/metadata/properties" ma:root="true" ma:fieldsID="a7d20d2c9a349b6838acf4b79389f2fd" ns2:_="" ns3:_="">
     <xsd:import namespace="fa937df2-abe2-4d38-b5f4-c228acba3827"/>
@@ -27195,32 +27182,27 @@
 </ct:contentTypeSchema>
 </file>
 
-<file path=customXml/itemProps1.xml><?xml version="1.0" encoding="utf-8"?>
-<ds:datastoreItem xmlns:ds="http://schemas.openxmlformats.org/officeDocument/2006/customXml" ds:itemID="{4B629362-CF15-4610-8FAC-A8E699942233}">
-  <ds:schemaRefs>
-    <ds:schemaRef ds:uri="http://schemas.microsoft.com/office/2006/documentManagement/types"/>
-    <ds:schemaRef ds:uri="http://purl.org/dc/elements/1.1/"/>
-    <ds:schemaRef ds:uri="bc8ba18a-4a58-4ad2-bfc0-6516af8e7dc2"/>
-    <ds:schemaRef ds:uri="http://purl.org/dc/terms/"/>
-    <ds:schemaRef ds:uri="http://www.w3.org/XML/1998/namespace"/>
-    <ds:schemaRef ds:uri="http://schemas.microsoft.com/office/2006/metadata/properties"/>
-    <ds:schemaRef ds:uri="http://schemas.microsoft.com/office/infopath/2007/PartnerControls"/>
-    <ds:schemaRef ds:uri="http://schemas.openxmlformats.org/package/2006/metadata/core-properties"/>
-    <ds:schemaRef ds:uri="fa937df2-abe2-4d38-b5f4-c228acba3827"/>
-    <ds:schemaRef ds:uri="http://purl.org/dc/dcmitype/"/>
-  </ds:schemaRefs>
-</ds:datastoreItem>
+<file path=customXml/item2.xml><?xml version="1.0" encoding="utf-8"?>
+<?mso-contentType ?>
+<FormTemplates xmlns="http://schemas.microsoft.com/sharepoint/v3/contenttype/forms">
+  <Display>DocumentLibraryForm</Display>
+  <Edit>DocumentLibraryForm</Edit>
+  <New>DocumentLibraryForm</New>
+</FormTemplates>
 </file>
 
-<file path=customXml/itemProps2.xml><?xml version="1.0" encoding="utf-8"?>
-<ds:datastoreItem xmlns:ds="http://schemas.openxmlformats.org/officeDocument/2006/customXml" ds:itemID="{570928F0-D7CA-4732-B7F3-1F945720D0AA}">
-  <ds:schemaRefs>
-    <ds:schemaRef ds:uri="http://schemas.microsoft.com/sharepoint/v3/contenttype/forms"/>
-  </ds:schemaRefs>
-</ds:datastoreItem>
+<file path=customXml/item3.xml><?xml version="1.0" encoding="utf-8"?>
+<p:properties xmlns:p="http://schemas.microsoft.com/office/2006/metadata/properties" xmlns:xsi="http://www.w3.org/2001/XMLSchema-instance" xmlns:pc="http://schemas.microsoft.com/office/infopath/2007/PartnerControls">
+  <documentManagement>
+    <lcf76f155ced4ddcb4097134ff3c332f xmlns="fa937df2-abe2-4d38-b5f4-c228acba3827">
+      <Terms xmlns="http://schemas.microsoft.com/office/infopath/2007/PartnerControls"/>
+    </lcf76f155ced4ddcb4097134ff3c332f>
+    <TaxCatchAll xmlns="bc8ba18a-4a58-4ad2-bfc0-6516af8e7dc2" xsi:nil="true"/>
+  </documentManagement>
+</p:properties>
 </file>
 
-<file path=customXml/itemProps3.xml><?xml version="1.0" encoding="utf-8"?>
+<file path=customXml/itemProps1.xml><?xml version="1.0" encoding="utf-8"?>
 <ds:datastoreItem xmlns:ds="http://schemas.openxmlformats.org/officeDocument/2006/customXml" ds:itemID="{06E6923A-C221-4753-B75B-BA213EEB7564}">
   <ds:schemaRefs>
     <ds:schemaRef ds:uri="bc8ba18a-4a58-4ad2-bfc0-6516af8e7dc2"/>
@@ -27237,4 +27219,29 @@
     <ds:schemaRef ds:uri="http://www.w3.org/2001/XMLSchema"/>
   </ds:schemaRefs>
 </ds:datastoreItem>
+</file>
+
+<file path=customXml/itemProps2.xml><?xml version="1.0" encoding="utf-8"?>
+<ds:datastoreItem xmlns:ds="http://schemas.openxmlformats.org/officeDocument/2006/customXml" ds:itemID="{570928F0-D7CA-4732-B7F3-1F945720D0AA}">
+  <ds:schemaRefs>
+    <ds:schemaRef ds:uri="http://schemas.microsoft.com/sharepoint/v3/contenttype/forms"/>
+  </ds:schemaRefs>
+</ds:datastoreItem>
+</file>
+
+<file path=customXml/itemProps3.xml><?xml version="1.0" encoding="utf-8"?>
+<ds:datastoreItem xmlns:ds="http://schemas.openxmlformats.org/officeDocument/2006/customXml" ds:itemID="{4B629362-CF15-4610-8FAC-A8E699942233}">
+  <ds:schemaRefs>
+    <ds:schemaRef ds:uri="http://schemas.microsoft.com/office/2006/documentManagement/types"/>
+    <ds:schemaRef ds:uri="http://purl.org/dc/elements/1.1/"/>
+    <ds:schemaRef ds:uri="bc8ba18a-4a58-4ad2-bfc0-6516af8e7dc2"/>
+    <ds:schemaRef ds:uri="http://purl.org/dc/terms/"/>
+    <ds:schemaRef ds:uri="http://www.w3.org/XML/1998/namespace"/>
+    <ds:schemaRef ds:uri="http://schemas.microsoft.com/office/2006/metadata/properties"/>
+    <ds:schemaRef ds:uri="http://schemas.microsoft.com/office/infopath/2007/PartnerControls"/>
+    <ds:schemaRef ds:uri="http://schemas.openxmlformats.org/package/2006/metadata/core-properties"/>
+    <ds:schemaRef ds:uri="fa937df2-abe2-4d38-b5f4-c228acba3827"/>
+    <ds:schemaRef ds:uri="http://purl.org/dc/dcmitype/"/>
+  </ds:schemaRefs>
+</ds:datastoreItem>
 </file>
</xml_diff>

<commit_message>
Update templates to unicode stars
</commit_message>
<xml_diff>
--- a/src/report_generator/presets/templates/itdd-technical-debt.pptx
+++ b/src/report_generator/presets/templates/itdd-technical-debt.pptx
@@ -262,7 +262,7 @@
           <a:p>
             <a:fld id="{C1255C68-584F-174D-BB81-51BF91708794}" type="datetimeFigureOut">
               <a:rPr lang="en-US" smtClean="0"/>
-              <a:t>1/29/26</a:t>
+              <a:t>2/23/26</a:t>
             </a:fld>
             <a:endParaRPr lang="en-US"/>
           </a:p>
@@ -439,7 +439,7 @@
           <a:p>
             <a:fld id="{A1EDAAC4-819D-C544-9EA1-C73624CFD70B}" type="datetimeFigureOut">
               <a:rPr lang="en-US" smtClean="0"/>
-              <a:t>1/29/26</a:t>
+              <a:t>2/23/26</a:t>
             </a:fld>
             <a:endParaRPr lang="en-US"/>
           </a:p>
@@ -25683,24 +25683,7 @@
                   <a:schemeClr val="accent1"/>
                 </a:solidFill>
               </a:rPr>
-              <a:t>is the estimated amount of development effort to improve the quality of the system to </a:t>
-            </a:r>
-            <a:r>
-              <a:rPr lang="en-US" sz="1200" dirty="0">
-                <a:solidFill>
-                  <a:schemeClr val="accent1"/>
-                </a:solidFill>
-                <a:latin typeface="Sigsterren" pitchFamily="2" charset="0"/>
-              </a:rPr>
-              <a:t>HHHHI</a:t>
-            </a:r>
-            <a:r>
-              <a:rPr lang="en-US" sz="1200" dirty="0">
-                <a:solidFill>
-                  <a:schemeClr val="accent1"/>
-                </a:solidFill>
-              </a:rPr>
-              <a:t> (3.5) maintainability rating.</a:t>
+              <a:t>is the estimated amount of development effort to improve the quality of the system to ★★★★☆ (3.5) maintainability rating.</a:t>
             </a:r>
             <a:endParaRPr lang="en-US" sz="1200" b="1" dirty="0">
               <a:solidFill>
@@ -26960,6 +26943,26 @@
 </file>
 
 <file path=customXml/item1.xml><?xml version="1.0" encoding="utf-8"?>
+<p:properties xmlns:p="http://schemas.microsoft.com/office/2006/metadata/properties" xmlns:xsi="http://www.w3.org/2001/XMLSchema-instance" xmlns:pc="http://schemas.microsoft.com/office/infopath/2007/PartnerControls">
+  <documentManagement>
+    <lcf76f155ced4ddcb4097134ff3c332f xmlns="fa937df2-abe2-4d38-b5f4-c228acba3827">
+      <Terms xmlns="http://schemas.microsoft.com/office/infopath/2007/PartnerControls"/>
+    </lcf76f155ced4ddcb4097134ff3c332f>
+    <TaxCatchAll xmlns="bc8ba18a-4a58-4ad2-bfc0-6516af8e7dc2" xsi:nil="true"/>
+  </documentManagement>
+</p:properties>
+</file>
+
+<file path=customXml/item2.xml><?xml version="1.0" encoding="utf-8"?>
+<?mso-contentType ?>
+<FormTemplates xmlns="http://schemas.microsoft.com/sharepoint/v3/contenttype/forms">
+  <Display>DocumentLibraryForm</Display>
+  <Edit>DocumentLibraryForm</Edit>
+  <New>DocumentLibraryForm</New>
+</FormTemplates>
+</file>
+
+<file path=customXml/item3.xml><?xml version="1.0" encoding="utf-8"?>
 <ct:contentTypeSchema xmlns:ct="http://schemas.microsoft.com/office/2006/metadata/contentType" xmlns:ma="http://schemas.microsoft.com/office/2006/metadata/properties/metaAttributes" ct:_="" ma:_="" ma:contentTypeName="Document" ma:contentTypeID="0x010100398B4EB28540854BB4092730D7F67224" ma:contentTypeVersion="13" ma:contentTypeDescription="Create a new document." ma:contentTypeScope="" ma:versionID="07d6997c7358ecc3b6f0d78039f1ac55">
   <xsd:schema xmlns:xsd="http://www.w3.org/2001/XMLSchema" xmlns:xs="http://www.w3.org/2001/XMLSchema" xmlns:p="http://schemas.microsoft.com/office/2006/metadata/properties" xmlns:ns2="fa937df2-abe2-4d38-b5f4-c228acba3827" xmlns:ns3="bc8ba18a-4a58-4ad2-bfc0-6516af8e7dc2" targetNamespace="http://schemas.microsoft.com/office/2006/metadata/properties" ma:root="true" ma:fieldsID="a7d20d2c9a349b6838acf4b79389f2fd" ns2:_="" ns3:_="">
     <xsd:import namespace="fa937df2-abe2-4d38-b5f4-c228acba3827"/>
@@ -27182,27 +27185,32 @@
 </ct:contentTypeSchema>
 </file>
 
-<file path=customXml/item2.xml><?xml version="1.0" encoding="utf-8"?>
-<?mso-contentType ?>
-<FormTemplates xmlns="http://schemas.microsoft.com/sharepoint/v3/contenttype/forms">
-  <Display>DocumentLibraryForm</Display>
-  <Edit>DocumentLibraryForm</Edit>
-  <New>DocumentLibraryForm</New>
-</FormTemplates>
+<file path=customXml/itemProps1.xml><?xml version="1.0" encoding="utf-8"?>
+<ds:datastoreItem xmlns:ds="http://schemas.openxmlformats.org/officeDocument/2006/customXml" ds:itemID="{4B629362-CF15-4610-8FAC-A8E699942233}">
+  <ds:schemaRefs>
+    <ds:schemaRef ds:uri="http://schemas.microsoft.com/office/2006/documentManagement/types"/>
+    <ds:schemaRef ds:uri="http://purl.org/dc/elements/1.1/"/>
+    <ds:schemaRef ds:uri="bc8ba18a-4a58-4ad2-bfc0-6516af8e7dc2"/>
+    <ds:schemaRef ds:uri="http://purl.org/dc/terms/"/>
+    <ds:schemaRef ds:uri="http://www.w3.org/XML/1998/namespace"/>
+    <ds:schemaRef ds:uri="http://schemas.microsoft.com/office/2006/metadata/properties"/>
+    <ds:schemaRef ds:uri="http://schemas.microsoft.com/office/infopath/2007/PartnerControls"/>
+    <ds:schemaRef ds:uri="http://schemas.openxmlformats.org/package/2006/metadata/core-properties"/>
+    <ds:schemaRef ds:uri="fa937df2-abe2-4d38-b5f4-c228acba3827"/>
+    <ds:schemaRef ds:uri="http://purl.org/dc/dcmitype/"/>
+  </ds:schemaRefs>
+</ds:datastoreItem>
 </file>
 
-<file path=customXml/item3.xml><?xml version="1.0" encoding="utf-8"?>
-<p:properties xmlns:p="http://schemas.microsoft.com/office/2006/metadata/properties" xmlns:xsi="http://www.w3.org/2001/XMLSchema-instance" xmlns:pc="http://schemas.microsoft.com/office/infopath/2007/PartnerControls">
-  <documentManagement>
-    <lcf76f155ced4ddcb4097134ff3c332f xmlns="fa937df2-abe2-4d38-b5f4-c228acba3827">
-      <Terms xmlns="http://schemas.microsoft.com/office/infopath/2007/PartnerControls"/>
-    </lcf76f155ced4ddcb4097134ff3c332f>
-    <TaxCatchAll xmlns="bc8ba18a-4a58-4ad2-bfc0-6516af8e7dc2" xsi:nil="true"/>
-  </documentManagement>
-</p:properties>
+<file path=customXml/itemProps2.xml><?xml version="1.0" encoding="utf-8"?>
+<ds:datastoreItem xmlns:ds="http://schemas.openxmlformats.org/officeDocument/2006/customXml" ds:itemID="{570928F0-D7CA-4732-B7F3-1F945720D0AA}">
+  <ds:schemaRefs>
+    <ds:schemaRef ds:uri="http://schemas.microsoft.com/sharepoint/v3/contenttype/forms"/>
+  </ds:schemaRefs>
+</ds:datastoreItem>
 </file>
 
-<file path=customXml/itemProps1.xml><?xml version="1.0" encoding="utf-8"?>
+<file path=customXml/itemProps3.xml><?xml version="1.0" encoding="utf-8"?>
 <ds:datastoreItem xmlns:ds="http://schemas.openxmlformats.org/officeDocument/2006/customXml" ds:itemID="{06E6923A-C221-4753-B75B-BA213EEB7564}">
   <ds:schemaRefs>
     <ds:schemaRef ds:uri="bc8ba18a-4a58-4ad2-bfc0-6516af8e7dc2"/>
@@ -27219,29 +27227,4 @@
     <ds:schemaRef ds:uri="http://www.w3.org/2001/XMLSchema"/>
   </ds:schemaRefs>
 </ds:datastoreItem>
-</file>
-
-<file path=customXml/itemProps2.xml><?xml version="1.0" encoding="utf-8"?>
-<ds:datastoreItem xmlns:ds="http://schemas.openxmlformats.org/officeDocument/2006/customXml" ds:itemID="{570928F0-D7CA-4732-B7F3-1F945720D0AA}">
-  <ds:schemaRefs>
-    <ds:schemaRef ds:uri="http://schemas.microsoft.com/sharepoint/v3/contenttype/forms"/>
-  </ds:schemaRefs>
-</ds:datastoreItem>
-</file>
-
-<file path=customXml/itemProps3.xml><?xml version="1.0" encoding="utf-8"?>
-<ds:datastoreItem xmlns:ds="http://schemas.openxmlformats.org/officeDocument/2006/customXml" ds:itemID="{4B629362-CF15-4610-8FAC-A8E699942233}">
-  <ds:schemaRefs>
-    <ds:schemaRef ds:uri="http://schemas.microsoft.com/office/2006/documentManagement/types"/>
-    <ds:schemaRef ds:uri="http://purl.org/dc/elements/1.1/"/>
-    <ds:schemaRef ds:uri="bc8ba18a-4a58-4ad2-bfc0-6516af8e7dc2"/>
-    <ds:schemaRef ds:uri="http://purl.org/dc/terms/"/>
-    <ds:schemaRef ds:uri="http://www.w3.org/XML/1998/namespace"/>
-    <ds:schemaRef ds:uri="http://schemas.microsoft.com/office/2006/metadata/properties"/>
-    <ds:schemaRef ds:uri="http://schemas.microsoft.com/office/infopath/2007/PartnerControls"/>
-    <ds:schemaRef ds:uri="http://schemas.openxmlformats.org/package/2006/metadata/core-properties"/>
-    <ds:schemaRef ds:uri="fa937df2-abe2-4d38-b5f4-c228acba3827"/>
-    <ds:schemaRef ds:uri="http://purl.org/dc/dcmitype/"/>
-  </ds:schemaRefs>
-</ds:datastoreItem>
 </file>
</xml_diff>

<commit_message>
Update integration tests that align with Sigrid
</commit_message>
<xml_diff>
--- a/src/report_generator/presets/templates/itdd-technical-debt.pptx
+++ b/src/report_generator/presets/templates/itdd-technical-debt.pptx
@@ -262,7 +262,7 @@
           <a:p>
             <a:fld id="{C1255C68-584F-174D-BB81-51BF91708794}" type="datetimeFigureOut">
               <a:rPr lang="en-US" smtClean="0"/>
-              <a:t>2/23/26</a:t>
+              <a:t>6/30/26</a:t>
             </a:fld>
             <a:endParaRPr lang="en-US"/>
           </a:p>
@@ -439,7 +439,7 @@
           <a:p>
             <a:fld id="{A1EDAAC4-819D-C544-9EA1-C73624CFD70B}" type="datetimeFigureOut">
               <a:rPr lang="en-US" smtClean="0"/>
-              <a:t>2/23/26</a:t>
+              <a:t>6/30/26</a:t>
             </a:fld>
             <a:endParaRPr lang="en-US"/>
           </a:p>
@@ -9560,12 +9560,12 @@
             <p:nvPr userDrawn="1"/>
           </p:nvPicPr>
           <p:blipFill>
-            <a:blip r:embed="rId2">
+            <a:blip>
               <a:lum bright="100000"/>
               <a:alphaModFix amt="80000"/>
               <a:extLst>
                 <a:ext uri="{96DAC541-7B7A-43D3-8B79-37D633B846F1}">
-                  <asvg:svgBlip xmlns:asvg="http://schemas.microsoft.com/office/drawing/2016/SVG/main" r:embed="rId3"/>
+                  <asvg:svgBlip xmlns:asvg="http://schemas.microsoft.com/office/drawing/2016/SVG/main" r:embed="rId2"/>
                 </a:ext>
               </a:extLst>
             </a:blip>
@@ -9677,12 +9677,12 @@
             <p:nvPr userDrawn="1"/>
           </p:nvPicPr>
           <p:blipFill>
-            <a:blip r:embed="rId4">
+            <a:blip>
               <a:lum bright="100000"/>
               <a:alphaModFix amt="80000"/>
               <a:extLst>
                 <a:ext uri="{96DAC541-7B7A-43D3-8B79-37D633B846F1}">
-                  <asvg:svgBlip xmlns:asvg="http://schemas.microsoft.com/office/drawing/2016/SVG/main" r:embed="rId5"/>
+                  <asvg:svgBlip xmlns:asvg="http://schemas.microsoft.com/office/drawing/2016/SVG/main" r:embed="rId3"/>
                 </a:ext>
               </a:extLst>
             </a:blip>
@@ -9794,12 +9794,12 @@
             <p:nvPr userDrawn="1"/>
           </p:nvPicPr>
           <p:blipFill>
-            <a:blip r:embed="rId6">
+            <a:blip>
               <a:lum bright="100000"/>
               <a:alphaModFix amt="80000"/>
               <a:extLst>
                 <a:ext uri="{96DAC541-7B7A-43D3-8B79-37D633B846F1}">
-                  <asvg:svgBlip xmlns:asvg="http://schemas.microsoft.com/office/drawing/2016/SVG/main" r:embed="rId7"/>
+                  <asvg:svgBlip xmlns:asvg="http://schemas.microsoft.com/office/drawing/2016/SVG/main" r:embed="rId4"/>
                 </a:ext>
               </a:extLst>
             </a:blip>
@@ -9900,12 +9900,12 @@
             <p:nvPr userDrawn="1"/>
           </p:nvPicPr>
           <p:blipFill>
-            <a:blip r:embed="rId8">
+            <a:blip>
               <a:lum bright="100000"/>
               <a:alphaModFix amt="80000"/>
               <a:extLst>
                 <a:ext uri="{96DAC541-7B7A-43D3-8B79-37D633B846F1}">
-                  <asvg:svgBlip xmlns:asvg="http://schemas.microsoft.com/office/drawing/2016/SVG/main" r:embed="rId9"/>
+                  <asvg:svgBlip xmlns:asvg="http://schemas.microsoft.com/office/drawing/2016/SVG/main" r:embed="rId5"/>
                 </a:ext>
               </a:extLst>
             </a:blip>
@@ -10028,12 +10028,12 @@
             <p:nvPr userDrawn="1"/>
           </p:nvPicPr>
           <p:blipFill>
-            <a:blip r:embed="rId10">
+            <a:blip>
               <a:lum bright="100000"/>
               <a:alphaModFix amt="80000"/>
               <a:extLst>
                 <a:ext uri="{96DAC541-7B7A-43D3-8B79-37D633B846F1}">
-                  <asvg:svgBlip xmlns:asvg="http://schemas.microsoft.com/office/drawing/2016/SVG/main" r:embed="rId11"/>
+                  <asvg:svgBlip xmlns:asvg="http://schemas.microsoft.com/office/drawing/2016/SVG/main" r:embed="rId6"/>
                 </a:ext>
               </a:extLst>
             </a:blip>
@@ -10134,12 +10134,12 @@
             <p:nvPr userDrawn="1"/>
           </p:nvPicPr>
           <p:blipFill>
-            <a:blip r:embed="rId12">
+            <a:blip>
               <a:lum bright="100000"/>
               <a:alphaModFix amt="80000"/>
               <a:extLst>
                 <a:ext uri="{96DAC541-7B7A-43D3-8B79-37D633B846F1}">
-                  <asvg:svgBlip xmlns:asvg="http://schemas.microsoft.com/office/drawing/2016/SVG/main" r:embed="rId13"/>
+                  <asvg:svgBlip xmlns:asvg="http://schemas.microsoft.com/office/drawing/2016/SVG/main" r:embed="rId7"/>
                 </a:ext>
               </a:extLst>
             </a:blip>
@@ -24716,7 +24716,7 @@
           <p:nvPr>
             <p:extLst>
               <p:ext uri="{D42A27DB-BD31-4B8C-83A1-F6EECF244321}">
-                <p14:modId xmlns:p14="http://schemas.microsoft.com/office/powerpoint/2010/main" val="2057082069"/>
+                <p14:modId xmlns:p14="http://schemas.microsoft.com/office/powerpoint/2010/main" val="2584800097"/>
               </p:ext>
             </p:extLst>
           </p:nvPr>
@@ -25256,7 +25256,27 @@
                           <a:effectLst/>
                           <a:latin typeface="Calibri Regular"/>
                         </a:rPr>
-                        <a:t>RENOVATION_EFFORT PY</a:t>
+                        <a:t>RENOVATION</a:t>
+                      </a:r>
+                      <a:r>
+                        <a:rPr lang="en-US" sz="1400" b="0" i="0" u="none" strike="noStrike" noProof="0">
+                          <a:solidFill>
+                            <a:srgbClr val="000000"/>
+                          </a:solidFill>
+                          <a:effectLst/>
+                          <a:latin typeface="Calibri Regular"/>
+                        </a:rPr>
+                        <a:t>_EFFORT_PY </a:t>
+                      </a:r>
+                      <a:r>
+                        <a:rPr lang="en-US" sz="1400" b="0" i="0" u="none" strike="noStrike" noProof="0" dirty="0">
+                          <a:solidFill>
+                            <a:srgbClr val="000000"/>
+                          </a:solidFill>
+                          <a:effectLst/>
+                          <a:latin typeface="Calibri Regular"/>
+                        </a:rPr>
+                        <a:t>PY</a:t>
                       </a:r>
                     </a:p>
                   </a:txBody>
@@ -26943,26 +26963,6 @@
 </file>
 
 <file path=customXml/item1.xml><?xml version="1.0" encoding="utf-8"?>
-<p:properties xmlns:p="http://schemas.microsoft.com/office/2006/metadata/properties" xmlns:xsi="http://www.w3.org/2001/XMLSchema-instance" xmlns:pc="http://schemas.microsoft.com/office/infopath/2007/PartnerControls">
-  <documentManagement>
-    <lcf76f155ced4ddcb4097134ff3c332f xmlns="fa937df2-abe2-4d38-b5f4-c228acba3827">
-      <Terms xmlns="http://schemas.microsoft.com/office/infopath/2007/PartnerControls"/>
-    </lcf76f155ced4ddcb4097134ff3c332f>
-    <TaxCatchAll xmlns="bc8ba18a-4a58-4ad2-bfc0-6516af8e7dc2" xsi:nil="true"/>
-  </documentManagement>
-</p:properties>
-</file>
-
-<file path=customXml/item2.xml><?xml version="1.0" encoding="utf-8"?>
-<?mso-contentType ?>
-<FormTemplates xmlns="http://schemas.microsoft.com/sharepoint/v3/contenttype/forms">
-  <Display>DocumentLibraryForm</Display>
-  <Edit>DocumentLibraryForm</Edit>
-  <New>DocumentLibraryForm</New>
-</FormTemplates>
-</file>
-
-<file path=customXml/item3.xml><?xml version="1.0" encoding="utf-8"?>
 <ct:contentTypeSchema xmlns:ct="http://schemas.microsoft.com/office/2006/metadata/contentType" xmlns:ma="http://schemas.microsoft.com/office/2006/metadata/properties/metaAttributes" ct:_="" ma:_="" ma:contentTypeName="Document" ma:contentTypeID="0x010100398B4EB28540854BB4092730D7F67224" ma:contentTypeVersion="13" ma:contentTypeDescription="Create a new document." ma:contentTypeScope="" ma:versionID="07d6997c7358ecc3b6f0d78039f1ac55">
   <xsd:schema xmlns:xsd="http://www.w3.org/2001/XMLSchema" xmlns:xs="http://www.w3.org/2001/XMLSchema" xmlns:p="http://schemas.microsoft.com/office/2006/metadata/properties" xmlns:ns2="fa937df2-abe2-4d38-b5f4-c228acba3827" xmlns:ns3="bc8ba18a-4a58-4ad2-bfc0-6516af8e7dc2" targetNamespace="http://schemas.microsoft.com/office/2006/metadata/properties" ma:root="true" ma:fieldsID="a7d20d2c9a349b6838acf4b79389f2fd" ns2:_="" ns3:_="">
     <xsd:import namespace="fa937df2-abe2-4d38-b5f4-c228acba3827"/>
@@ -27185,32 +27185,27 @@
 </ct:contentTypeSchema>
 </file>
 
-<file path=customXml/itemProps1.xml><?xml version="1.0" encoding="utf-8"?>
-<ds:datastoreItem xmlns:ds="http://schemas.openxmlformats.org/officeDocument/2006/customXml" ds:itemID="{4B629362-CF15-4610-8FAC-A8E699942233}">
-  <ds:schemaRefs>
-    <ds:schemaRef ds:uri="http://schemas.microsoft.com/office/2006/documentManagement/types"/>
-    <ds:schemaRef ds:uri="http://purl.org/dc/elements/1.1/"/>
-    <ds:schemaRef ds:uri="bc8ba18a-4a58-4ad2-bfc0-6516af8e7dc2"/>
-    <ds:schemaRef ds:uri="http://purl.org/dc/terms/"/>
-    <ds:schemaRef ds:uri="http://www.w3.org/XML/1998/namespace"/>
-    <ds:schemaRef ds:uri="http://schemas.microsoft.com/office/2006/metadata/properties"/>
-    <ds:schemaRef ds:uri="http://schemas.microsoft.com/office/infopath/2007/PartnerControls"/>
-    <ds:schemaRef ds:uri="http://schemas.openxmlformats.org/package/2006/metadata/core-properties"/>
-    <ds:schemaRef ds:uri="fa937df2-abe2-4d38-b5f4-c228acba3827"/>
-    <ds:schemaRef ds:uri="http://purl.org/dc/dcmitype/"/>
-  </ds:schemaRefs>
-</ds:datastoreItem>
+<file path=customXml/item2.xml><?xml version="1.0" encoding="utf-8"?>
+<?mso-contentType ?>
+<FormTemplates xmlns="http://schemas.microsoft.com/sharepoint/v3/contenttype/forms">
+  <Display>DocumentLibraryForm</Display>
+  <Edit>DocumentLibraryForm</Edit>
+  <New>DocumentLibraryForm</New>
+</FormTemplates>
 </file>
 
-<file path=customXml/itemProps2.xml><?xml version="1.0" encoding="utf-8"?>
-<ds:datastoreItem xmlns:ds="http://schemas.openxmlformats.org/officeDocument/2006/customXml" ds:itemID="{570928F0-D7CA-4732-B7F3-1F945720D0AA}">
-  <ds:schemaRefs>
-    <ds:schemaRef ds:uri="http://schemas.microsoft.com/sharepoint/v3/contenttype/forms"/>
-  </ds:schemaRefs>
-</ds:datastoreItem>
+<file path=customXml/item3.xml><?xml version="1.0" encoding="utf-8"?>
+<p:properties xmlns:p="http://schemas.microsoft.com/office/2006/metadata/properties" xmlns:xsi="http://www.w3.org/2001/XMLSchema-instance" xmlns:pc="http://schemas.microsoft.com/office/infopath/2007/PartnerControls">
+  <documentManagement>
+    <lcf76f155ced4ddcb4097134ff3c332f xmlns="fa937df2-abe2-4d38-b5f4-c228acba3827">
+      <Terms xmlns="http://schemas.microsoft.com/office/infopath/2007/PartnerControls"/>
+    </lcf76f155ced4ddcb4097134ff3c332f>
+    <TaxCatchAll xmlns="bc8ba18a-4a58-4ad2-bfc0-6516af8e7dc2" xsi:nil="true"/>
+  </documentManagement>
+</p:properties>
 </file>
 
-<file path=customXml/itemProps3.xml><?xml version="1.0" encoding="utf-8"?>
+<file path=customXml/itemProps1.xml><?xml version="1.0" encoding="utf-8"?>
 <ds:datastoreItem xmlns:ds="http://schemas.openxmlformats.org/officeDocument/2006/customXml" ds:itemID="{06E6923A-C221-4753-B75B-BA213EEB7564}">
   <ds:schemaRefs>
     <ds:schemaRef ds:uri="bc8ba18a-4a58-4ad2-bfc0-6516af8e7dc2"/>
@@ -27227,4 +27222,29 @@
     <ds:schemaRef ds:uri="http://www.w3.org/2001/XMLSchema"/>
   </ds:schemaRefs>
 </ds:datastoreItem>
+</file>
+
+<file path=customXml/itemProps2.xml><?xml version="1.0" encoding="utf-8"?>
+<ds:datastoreItem xmlns:ds="http://schemas.openxmlformats.org/officeDocument/2006/customXml" ds:itemID="{570928F0-D7CA-4732-B7F3-1F945720D0AA}">
+  <ds:schemaRefs>
+    <ds:schemaRef ds:uri="http://schemas.microsoft.com/sharepoint/v3/contenttype/forms"/>
+  </ds:schemaRefs>
+</ds:datastoreItem>
+</file>
+
+<file path=customXml/itemProps3.xml><?xml version="1.0" encoding="utf-8"?>
+<ds:datastoreItem xmlns:ds="http://schemas.openxmlformats.org/officeDocument/2006/customXml" ds:itemID="{4B629362-CF15-4610-8FAC-A8E699942233}">
+  <ds:schemaRefs>
+    <ds:schemaRef ds:uri="http://schemas.microsoft.com/office/2006/documentManagement/types"/>
+    <ds:schemaRef ds:uri="http://purl.org/dc/elements/1.1/"/>
+    <ds:schemaRef ds:uri="bc8ba18a-4a58-4ad2-bfc0-6516af8e7dc2"/>
+    <ds:schemaRef ds:uri="http://purl.org/dc/terms/"/>
+    <ds:schemaRef ds:uri="http://www.w3.org/XML/1998/namespace"/>
+    <ds:schemaRef ds:uri="http://schemas.microsoft.com/office/2006/metadata/properties"/>
+    <ds:schemaRef ds:uri="http://schemas.microsoft.com/office/infopath/2007/PartnerControls"/>
+    <ds:schemaRef ds:uri="http://schemas.openxmlformats.org/package/2006/metadata/core-properties"/>
+    <ds:schemaRef ds:uri="fa937df2-abe2-4d38-b5f4-c228acba3827"/>
+    <ds:schemaRef ds:uri="http://purl.org/dc/dcmitype/"/>
+  </ds:schemaRefs>
+</ds:datastoreItem>
 </file>
</xml_diff>

<commit_message>
Don't stop looping paragraphs after a placeholder match (#53)
* Don't stop looping paragraphs after a placeholder match

* Change regex to re.search

* Update integration tests that align with Sigrid
</commit_message>
<xml_diff>
--- a/src/report_generator/presets/templates/itdd-technical-debt.pptx
+++ b/src/report_generator/presets/templates/itdd-technical-debt.pptx
@@ -262,7 +262,7 @@
           <a:p>
             <a:fld id="{C1255C68-584F-174D-BB81-51BF91708794}" type="datetimeFigureOut">
               <a:rPr lang="en-US" smtClean="0"/>
-              <a:t>2/23/26</a:t>
+              <a:t>6/30/26</a:t>
             </a:fld>
             <a:endParaRPr lang="en-US"/>
           </a:p>
@@ -439,7 +439,7 @@
           <a:p>
             <a:fld id="{A1EDAAC4-819D-C544-9EA1-C73624CFD70B}" type="datetimeFigureOut">
               <a:rPr lang="en-US" smtClean="0"/>
-              <a:t>2/23/26</a:t>
+              <a:t>6/30/26</a:t>
             </a:fld>
             <a:endParaRPr lang="en-US"/>
           </a:p>
@@ -9560,12 +9560,12 @@
             <p:nvPr userDrawn="1"/>
           </p:nvPicPr>
           <p:blipFill>
-            <a:blip r:embed="rId2">
+            <a:blip>
               <a:lum bright="100000"/>
               <a:alphaModFix amt="80000"/>
               <a:extLst>
                 <a:ext uri="{96DAC541-7B7A-43D3-8B79-37D633B846F1}">
-                  <asvg:svgBlip xmlns:asvg="http://schemas.microsoft.com/office/drawing/2016/SVG/main" r:embed="rId3"/>
+                  <asvg:svgBlip xmlns:asvg="http://schemas.microsoft.com/office/drawing/2016/SVG/main" r:embed="rId2"/>
                 </a:ext>
               </a:extLst>
             </a:blip>
@@ -9677,12 +9677,12 @@
             <p:nvPr userDrawn="1"/>
           </p:nvPicPr>
           <p:blipFill>
-            <a:blip r:embed="rId4">
+            <a:blip>
               <a:lum bright="100000"/>
               <a:alphaModFix amt="80000"/>
               <a:extLst>
                 <a:ext uri="{96DAC541-7B7A-43D3-8B79-37D633B846F1}">
-                  <asvg:svgBlip xmlns:asvg="http://schemas.microsoft.com/office/drawing/2016/SVG/main" r:embed="rId5"/>
+                  <asvg:svgBlip xmlns:asvg="http://schemas.microsoft.com/office/drawing/2016/SVG/main" r:embed="rId3"/>
                 </a:ext>
               </a:extLst>
             </a:blip>
@@ -9794,12 +9794,12 @@
             <p:nvPr userDrawn="1"/>
           </p:nvPicPr>
           <p:blipFill>
-            <a:blip r:embed="rId6">
+            <a:blip>
               <a:lum bright="100000"/>
               <a:alphaModFix amt="80000"/>
               <a:extLst>
                 <a:ext uri="{96DAC541-7B7A-43D3-8B79-37D633B846F1}">
-                  <asvg:svgBlip xmlns:asvg="http://schemas.microsoft.com/office/drawing/2016/SVG/main" r:embed="rId7"/>
+                  <asvg:svgBlip xmlns:asvg="http://schemas.microsoft.com/office/drawing/2016/SVG/main" r:embed="rId4"/>
                 </a:ext>
               </a:extLst>
             </a:blip>
@@ -9900,12 +9900,12 @@
             <p:nvPr userDrawn="1"/>
           </p:nvPicPr>
           <p:blipFill>
-            <a:blip r:embed="rId8">
+            <a:blip>
               <a:lum bright="100000"/>
               <a:alphaModFix amt="80000"/>
               <a:extLst>
                 <a:ext uri="{96DAC541-7B7A-43D3-8B79-37D633B846F1}">
-                  <asvg:svgBlip xmlns:asvg="http://schemas.microsoft.com/office/drawing/2016/SVG/main" r:embed="rId9"/>
+                  <asvg:svgBlip xmlns:asvg="http://schemas.microsoft.com/office/drawing/2016/SVG/main" r:embed="rId5"/>
                 </a:ext>
               </a:extLst>
             </a:blip>
@@ -10028,12 +10028,12 @@
             <p:nvPr userDrawn="1"/>
           </p:nvPicPr>
           <p:blipFill>
-            <a:blip r:embed="rId10">
+            <a:blip>
               <a:lum bright="100000"/>
               <a:alphaModFix amt="80000"/>
               <a:extLst>
                 <a:ext uri="{96DAC541-7B7A-43D3-8B79-37D633B846F1}">
-                  <asvg:svgBlip xmlns:asvg="http://schemas.microsoft.com/office/drawing/2016/SVG/main" r:embed="rId11"/>
+                  <asvg:svgBlip xmlns:asvg="http://schemas.microsoft.com/office/drawing/2016/SVG/main" r:embed="rId6"/>
                 </a:ext>
               </a:extLst>
             </a:blip>
@@ -10134,12 +10134,12 @@
             <p:nvPr userDrawn="1"/>
           </p:nvPicPr>
           <p:blipFill>
-            <a:blip r:embed="rId12">
+            <a:blip>
               <a:lum bright="100000"/>
               <a:alphaModFix amt="80000"/>
               <a:extLst>
                 <a:ext uri="{96DAC541-7B7A-43D3-8B79-37D633B846F1}">
-                  <asvg:svgBlip xmlns:asvg="http://schemas.microsoft.com/office/drawing/2016/SVG/main" r:embed="rId13"/>
+                  <asvg:svgBlip xmlns:asvg="http://schemas.microsoft.com/office/drawing/2016/SVG/main" r:embed="rId7"/>
                 </a:ext>
               </a:extLst>
             </a:blip>
@@ -24716,7 +24716,7 @@
           <p:nvPr>
             <p:extLst>
               <p:ext uri="{D42A27DB-BD31-4B8C-83A1-F6EECF244321}">
-                <p14:modId xmlns:p14="http://schemas.microsoft.com/office/powerpoint/2010/main" val="2057082069"/>
+                <p14:modId xmlns:p14="http://schemas.microsoft.com/office/powerpoint/2010/main" val="2584800097"/>
               </p:ext>
             </p:extLst>
           </p:nvPr>
@@ -25256,7 +25256,27 @@
                           <a:effectLst/>
                           <a:latin typeface="Calibri Regular"/>
                         </a:rPr>
-                        <a:t>RENOVATION_EFFORT PY</a:t>
+                        <a:t>RENOVATION</a:t>
+                      </a:r>
+                      <a:r>
+                        <a:rPr lang="en-US" sz="1400" b="0" i="0" u="none" strike="noStrike" noProof="0">
+                          <a:solidFill>
+                            <a:srgbClr val="000000"/>
+                          </a:solidFill>
+                          <a:effectLst/>
+                          <a:latin typeface="Calibri Regular"/>
+                        </a:rPr>
+                        <a:t>_EFFORT_PY </a:t>
+                      </a:r>
+                      <a:r>
+                        <a:rPr lang="en-US" sz="1400" b="0" i="0" u="none" strike="noStrike" noProof="0" dirty="0">
+                          <a:solidFill>
+                            <a:srgbClr val="000000"/>
+                          </a:solidFill>
+                          <a:effectLst/>
+                          <a:latin typeface="Calibri Regular"/>
+                        </a:rPr>
+                        <a:t>PY</a:t>
                       </a:r>
                     </a:p>
                   </a:txBody>
@@ -26943,26 +26963,6 @@
 </file>
 
 <file path=customXml/item1.xml><?xml version="1.0" encoding="utf-8"?>
-<p:properties xmlns:p="http://schemas.microsoft.com/office/2006/metadata/properties" xmlns:xsi="http://www.w3.org/2001/XMLSchema-instance" xmlns:pc="http://schemas.microsoft.com/office/infopath/2007/PartnerControls">
-  <documentManagement>
-    <lcf76f155ced4ddcb4097134ff3c332f xmlns="fa937df2-abe2-4d38-b5f4-c228acba3827">
-      <Terms xmlns="http://schemas.microsoft.com/office/infopath/2007/PartnerControls"/>
-    </lcf76f155ced4ddcb4097134ff3c332f>
-    <TaxCatchAll xmlns="bc8ba18a-4a58-4ad2-bfc0-6516af8e7dc2" xsi:nil="true"/>
-  </documentManagement>
-</p:properties>
-</file>
-
-<file path=customXml/item2.xml><?xml version="1.0" encoding="utf-8"?>
-<?mso-contentType ?>
-<FormTemplates xmlns="http://schemas.microsoft.com/sharepoint/v3/contenttype/forms">
-  <Display>DocumentLibraryForm</Display>
-  <Edit>DocumentLibraryForm</Edit>
-  <New>DocumentLibraryForm</New>
-</FormTemplates>
-</file>
-
-<file path=customXml/item3.xml><?xml version="1.0" encoding="utf-8"?>
 <ct:contentTypeSchema xmlns:ct="http://schemas.microsoft.com/office/2006/metadata/contentType" xmlns:ma="http://schemas.microsoft.com/office/2006/metadata/properties/metaAttributes" ct:_="" ma:_="" ma:contentTypeName="Document" ma:contentTypeID="0x010100398B4EB28540854BB4092730D7F67224" ma:contentTypeVersion="13" ma:contentTypeDescription="Create a new document." ma:contentTypeScope="" ma:versionID="07d6997c7358ecc3b6f0d78039f1ac55">
   <xsd:schema xmlns:xsd="http://www.w3.org/2001/XMLSchema" xmlns:xs="http://www.w3.org/2001/XMLSchema" xmlns:p="http://schemas.microsoft.com/office/2006/metadata/properties" xmlns:ns2="fa937df2-abe2-4d38-b5f4-c228acba3827" xmlns:ns3="bc8ba18a-4a58-4ad2-bfc0-6516af8e7dc2" targetNamespace="http://schemas.microsoft.com/office/2006/metadata/properties" ma:root="true" ma:fieldsID="a7d20d2c9a349b6838acf4b79389f2fd" ns2:_="" ns3:_="">
     <xsd:import namespace="fa937df2-abe2-4d38-b5f4-c228acba3827"/>
@@ -27185,32 +27185,27 @@
 </ct:contentTypeSchema>
 </file>
 
-<file path=customXml/itemProps1.xml><?xml version="1.0" encoding="utf-8"?>
-<ds:datastoreItem xmlns:ds="http://schemas.openxmlformats.org/officeDocument/2006/customXml" ds:itemID="{4B629362-CF15-4610-8FAC-A8E699942233}">
-  <ds:schemaRefs>
-    <ds:schemaRef ds:uri="http://schemas.microsoft.com/office/2006/documentManagement/types"/>
-    <ds:schemaRef ds:uri="http://purl.org/dc/elements/1.1/"/>
-    <ds:schemaRef ds:uri="bc8ba18a-4a58-4ad2-bfc0-6516af8e7dc2"/>
-    <ds:schemaRef ds:uri="http://purl.org/dc/terms/"/>
-    <ds:schemaRef ds:uri="http://www.w3.org/XML/1998/namespace"/>
-    <ds:schemaRef ds:uri="http://schemas.microsoft.com/office/2006/metadata/properties"/>
-    <ds:schemaRef ds:uri="http://schemas.microsoft.com/office/infopath/2007/PartnerControls"/>
-    <ds:schemaRef ds:uri="http://schemas.openxmlformats.org/package/2006/metadata/core-properties"/>
-    <ds:schemaRef ds:uri="fa937df2-abe2-4d38-b5f4-c228acba3827"/>
-    <ds:schemaRef ds:uri="http://purl.org/dc/dcmitype/"/>
-  </ds:schemaRefs>
-</ds:datastoreItem>
+<file path=customXml/item2.xml><?xml version="1.0" encoding="utf-8"?>
+<?mso-contentType ?>
+<FormTemplates xmlns="http://schemas.microsoft.com/sharepoint/v3/contenttype/forms">
+  <Display>DocumentLibraryForm</Display>
+  <Edit>DocumentLibraryForm</Edit>
+  <New>DocumentLibraryForm</New>
+</FormTemplates>
 </file>
 
-<file path=customXml/itemProps2.xml><?xml version="1.0" encoding="utf-8"?>
-<ds:datastoreItem xmlns:ds="http://schemas.openxmlformats.org/officeDocument/2006/customXml" ds:itemID="{570928F0-D7CA-4732-B7F3-1F945720D0AA}">
-  <ds:schemaRefs>
-    <ds:schemaRef ds:uri="http://schemas.microsoft.com/sharepoint/v3/contenttype/forms"/>
-  </ds:schemaRefs>
-</ds:datastoreItem>
+<file path=customXml/item3.xml><?xml version="1.0" encoding="utf-8"?>
+<p:properties xmlns:p="http://schemas.microsoft.com/office/2006/metadata/properties" xmlns:xsi="http://www.w3.org/2001/XMLSchema-instance" xmlns:pc="http://schemas.microsoft.com/office/infopath/2007/PartnerControls">
+  <documentManagement>
+    <lcf76f155ced4ddcb4097134ff3c332f xmlns="fa937df2-abe2-4d38-b5f4-c228acba3827">
+      <Terms xmlns="http://schemas.microsoft.com/office/infopath/2007/PartnerControls"/>
+    </lcf76f155ced4ddcb4097134ff3c332f>
+    <TaxCatchAll xmlns="bc8ba18a-4a58-4ad2-bfc0-6516af8e7dc2" xsi:nil="true"/>
+  </documentManagement>
+</p:properties>
 </file>
 
-<file path=customXml/itemProps3.xml><?xml version="1.0" encoding="utf-8"?>
+<file path=customXml/itemProps1.xml><?xml version="1.0" encoding="utf-8"?>
 <ds:datastoreItem xmlns:ds="http://schemas.openxmlformats.org/officeDocument/2006/customXml" ds:itemID="{06E6923A-C221-4753-B75B-BA213EEB7564}">
   <ds:schemaRefs>
     <ds:schemaRef ds:uri="bc8ba18a-4a58-4ad2-bfc0-6516af8e7dc2"/>
@@ -27227,4 +27222,29 @@
     <ds:schemaRef ds:uri="http://www.w3.org/2001/XMLSchema"/>
   </ds:schemaRefs>
 </ds:datastoreItem>
+</file>
+
+<file path=customXml/itemProps2.xml><?xml version="1.0" encoding="utf-8"?>
+<ds:datastoreItem xmlns:ds="http://schemas.openxmlformats.org/officeDocument/2006/customXml" ds:itemID="{570928F0-D7CA-4732-B7F3-1F945720D0AA}">
+  <ds:schemaRefs>
+    <ds:schemaRef ds:uri="http://schemas.microsoft.com/sharepoint/v3/contenttype/forms"/>
+  </ds:schemaRefs>
+</ds:datastoreItem>
+</file>
+
+<file path=customXml/itemProps3.xml><?xml version="1.0" encoding="utf-8"?>
+<ds:datastoreItem xmlns:ds="http://schemas.openxmlformats.org/officeDocument/2006/customXml" ds:itemID="{4B629362-CF15-4610-8FAC-A8E699942233}">
+  <ds:schemaRefs>
+    <ds:schemaRef ds:uri="http://schemas.microsoft.com/office/2006/documentManagement/types"/>
+    <ds:schemaRef ds:uri="http://purl.org/dc/elements/1.1/"/>
+    <ds:schemaRef ds:uri="bc8ba18a-4a58-4ad2-bfc0-6516af8e7dc2"/>
+    <ds:schemaRef ds:uri="http://purl.org/dc/terms/"/>
+    <ds:schemaRef ds:uri="http://www.w3.org/XML/1998/namespace"/>
+    <ds:schemaRef ds:uri="http://schemas.microsoft.com/office/2006/metadata/properties"/>
+    <ds:schemaRef ds:uri="http://schemas.microsoft.com/office/infopath/2007/PartnerControls"/>
+    <ds:schemaRef ds:uri="http://schemas.openxmlformats.org/package/2006/metadata/core-properties"/>
+    <ds:schemaRef ds:uri="fa937df2-abe2-4d38-b5f4-c228acba3827"/>
+    <ds:schemaRef ds:uri="http://purl.org/dc/dcmitype/"/>
+  </ds:schemaRefs>
+</ds:datastoreItem>
 </file>
</xml_diff>